<commit_message>
Some minor coloring changes
</commit_message>
<xml_diff>
--- a/lectures/Week05_ChainingFinalOverload_Generics/1_ConstructorChainingFinalMethodsClassesOverloading_V4.pptx
+++ b/lectures/Week05_ChainingFinalOverload_Generics/1_ConstructorChainingFinalMethodsClassesOverloading_V4.pptx
@@ -234,7 +234,7 @@
           <a:p>
             <a:fld id="{8E938536-29D3-49BD-A567-41CAF057586A}" type="datetimeFigureOut">
               <a:rPr lang="en-US" smtClean="0"/>
-              <a:t>9/23/2026</a:t>
+              <a:t>10/21/2026</a:t>
             </a:fld>
             <a:endParaRPr lang="en-US"/>
           </a:p>
@@ -399,7 +399,7 @@
           <a:p>
             <a:fld id="{71559A16-B3AD-4CE2-9A5E-FAAD3C2C27CA}" type="datetimeFigureOut">
               <a:rPr lang="en-US" smtClean="0"/>
-              <a:t>9/23/2026</a:t>
+              <a:t>10/21/2026</a:t>
             </a:fld>
             <a:endParaRPr lang="en-US"/>
           </a:p>
@@ -2170,7 +2170,7 @@
           <a:p>
             <a:fld id="{14C656F1-AD33-45CA-85C7-DC330226D9FE}" type="datetime1">
               <a:rPr lang="en-US" smtClean="0"/>
-              <a:t>9/23/2026</a:t>
+              <a:t>10/21/2026</a:t>
             </a:fld>
             <a:endParaRPr lang="en-US"/>
           </a:p>
@@ -8572,6 +8572,45 @@
           </a:p>
         </p:txBody>
       </p:sp>
+      <p:sp>
+        <p:nvSpPr>
+          <p:cNvPr id="2" name="TextBox 1">
+            <a:extLst>
+              <a:ext uri="{FF2B5EF4-FFF2-40B4-BE49-F238E27FC236}">
+                <a16:creationId xmlns:a16="http://schemas.microsoft.com/office/drawing/2014/main" id="{BFCEC2BC-8287-4953-3D66-6F6CBD724A83}"/>
+              </a:ext>
+            </a:extLst>
+          </p:cNvPr>
+          <p:cNvSpPr txBox="1"/>
+          <p:nvPr/>
+        </p:nvSpPr>
+        <p:spPr>
+          <a:xfrm>
+            <a:off x="3579963" y="4873925"/>
+            <a:ext cx="2069797" cy="369332"/>
+          </a:xfrm>
+          <a:prstGeom prst="rect">
+            <a:avLst/>
+          </a:prstGeom>
+          <a:noFill/>
+        </p:spPr>
+        <p:txBody>
+          <a:bodyPr wrap="none" rtlCol="0">
+            <a:spAutoFit/>
+          </a:bodyPr>
+          <a:lstStyle/>
+          <a:p>
+            <a:r>
+              <a:rPr lang="en-US" b="1" u="sng" dirty="0">
+                <a:solidFill>
+                  <a:srgbClr val="FF0000"/>
+                </a:solidFill>
+              </a:rPr>
+              <a:t>Not possible in C</a:t>
+            </a:r>
+          </a:p>
+        </p:txBody>
+      </p:sp>
     </p:spTree>
     <p:extLst>
       <p:ext uri="{BB962C8B-B14F-4D97-AF65-F5344CB8AC3E}">
@@ -9782,16 +9821,16 @@
         </p:nvSpPr>
         <p:spPr>
           <a:xfrm>
-            <a:off x="4818807" y="2180804"/>
-            <a:ext cx="2930874" cy="619040"/>
+            <a:off x="6142009" y="2163552"/>
+            <a:ext cx="448574" cy="208713"/>
           </a:xfrm>
           <a:prstGeom prst="rect">
             <a:avLst/>
           </a:prstGeom>
           <a:noFill/>
-          <a:ln w="19050">
+          <a:ln w="28575">
             <a:solidFill>
-              <a:srgbClr val="92D050"/>
+              <a:srgbClr val="FF0000"/>
             </a:solidFill>
           </a:ln>
         </p:spPr>
@@ -10117,6 +10156,58 @@
               </a:rPr>
               <a:t> &amp; Bar”</a:t>
             </a:r>
+          </a:p>
+        </p:txBody>
+      </p:sp>
+      <p:sp>
+        <p:nvSpPr>
+          <p:cNvPr id="9" name="Rectangle 8">
+            <a:extLst>
+              <a:ext uri="{FF2B5EF4-FFF2-40B4-BE49-F238E27FC236}">
+                <a16:creationId xmlns:a16="http://schemas.microsoft.com/office/drawing/2014/main" id="{0E0DCEC0-5348-CCEC-0CC7-FE639E4F2119}"/>
+              </a:ext>
+            </a:extLst>
+          </p:cNvPr>
+          <p:cNvSpPr/>
+          <p:nvPr/>
+        </p:nvSpPr>
+        <p:spPr>
+          <a:xfrm>
+            <a:off x="6152161" y="3335401"/>
+            <a:ext cx="1007764" cy="208713"/>
+          </a:xfrm>
+          <a:prstGeom prst="rect">
+            <a:avLst/>
+          </a:prstGeom>
+          <a:noFill/>
+          <a:ln w="28575">
+            <a:solidFill>
+              <a:srgbClr val="FF0000"/>
+            </a:solidFill>
+          </a:ln>
+        </p:spPr>
+        <p:style>
+          <a:lnRef idx="2">
+            <a:schemeClr val="accent1">
+              <a:shade val="50000"/>
+            </a:schemeClr>
+          </a:lnRef>
+          <a:fillRef idx="1">
+            <a:schemeClr val="accent1"/>
+          </a:fillRef>
+          <a:effectRef idx="0">
+            <a:schemeClr val="accent1"/>
+          </a:effectRef>
+          <a:fontRef idx="minor">
+            <a:schemeClr val="lt1"/>
+          </a:fontRef>
+        </p:style>
+        <p:txBody>
+          <a:bodyPr rtlCol="0" anchor="ctr"/>
+          <a:lstStyle/>
+          <a:p>
+            <a:pPr algn="ctr"/>
+            <a:endParaRPr lang="en-US"/>
           </a:p>
         </p:txBody>
       </p:sp>
@@ -10497,7 +10588,7 @@
             <a:r>
               <a:rPr lang="en-US" altLang="en-US" sz="2800" b="1" dirty="0">
                 <a:solidFill>
-                  <a:srgbClr val="800000"/>
+                  <a:srgbClr val="FF0000"/>
                 </a:solidFill>
               </a:rPr>
               <a:t>override</a:t>
@@ -10537,7 +10628,11 @@
           <a:p>
             <a:pPr lvl="1" eaLnBrk="1" hangingPunct="1"/>
             <a:r>
-              <a:rPr lang="en-US" altLang="en-US" dirty="0"/>
+              <a:rPr lang="en-US" altLang="en-US" dirty="0">
+                <a:solidFill>
+                  <a:schemeClr val="tx1"/>
+                </a:solidFill>
+              </a:rPr>
               <a:t>Both methods have the </a:t>
             </a:r>
             <a:r>
@@ -10556,97 +10651,165 @@
           <a:p>
             <a:pPr lvl="1" eaLnBrk="1" hangingPunct="1"/>
             <a:r>
+              <a:rPr lang="en-US" altLang="en-US" dirty="0">
+                <a:solidFill>
+                  <a:schemeClr val="tx1"/>
+                </a:solidFill>
+              </a:rPr>
+              <a:t>The derived class method can be a </a:t>
+            </a:r>
+            <a:r>
+              <a:rPr lang="en-US" altLang="en-US" b="1" i="1" dirty="0">
+                <a:solidFill>
+                  <a:srgbClr val="00B0F0"/>
+                </a:solidFill>
+              </a:rPr>
+              <a:t>refinement</a:t>
+            </a:r>
+            <a:r>
               <a:rPr lang="en-US" altLang="en-US" dirty="0"/>
-              <a:t>The derived class method can be a </a:t>
-            </a:r>
-            <a:r>
-              <a:rPr lang="en-US" altLang="en-US" b="1" i="1" dirty="0">
-                <a:solidFill>
-                  <a:srgbClr val="00B0F0"/>
-                </a:solidFill>
-              </a:rPr>
-              <a:t>refinement</a:t>
+              <a:t> </a:t>
+            </a:r>
+            <a:r>
+              <a:rPr lang="en-US" altLang="en-US" dirty="0">
+                <a:solidFill>
+                  <a:schemeClr val="tx1"/>
+                </a:solidFill>
+              </a:rPr>
+              <a:t>of the base class method. </a:t>
+            </a:r>
+          </a:p>
+          <a:p>
+            <a:pPr lvl="1" eaLnBrk="1" hangingPunct="1"/>
+            <a:endParaRPr lang="en-US" altLang="en-US" dirty="0">
+              <a:solidFill>
+                <a:schemeClr val="tx1"/>
+              </a:solidFill>
+            </a:endParaRPr>
+          </a:p>
+          <a:p>
+            <a:pPr lvl="1" eaLnBrk="1" hangingPunct="1"/>
+            <a:r>
+              <a:rPr lang="en-US" altLang="en-US" dirty="0">
+                <a:solidFill>
+                  <a:schemeClr val="tx1"/>
+                </a:solidFill>
+              </a:rPr>
+              <a:t>Eg: the </a:t>
+            </a:r>
+            <a:r>
+              <a:rPr lang="en-US" altLang="en-US" dirty="0">
+                <a:solidFill>
+                  <a:srgbClr val="FF0000"/>
+                </a:solidFill>
+              </a:rPr>
+              <a:t>print()</a:t>
             </a:r>
             <a:r>
               <a:rPr lang="en-US" altLang="en-US" dirty="0"/>
-              <a:t> of the base class method. </a:t>
+              <a:t> </a:t>
+            </a:r>
+            <a:r>
+              <a:rPr lang="en-US" altLang="en-US" dirty="0">
+                <a:solidFill>
+                  <a:schemeClr val="tx1"/>
+                </a:solidFill>
+              </a:rPr>
+              <a:t>in classes Circle and Rectangle in </a:t>
+            </a:r>
+            <a:r>
+              <a:rPr lang="en-US" altLang="en-US" b="1" dirty="0">
+                <a:solidFill>
+                  <a:schemeClr val="tx1"/>
+                </a:solidFill>
+              </a:rPr>
+              <a:t>Shapes</a:t>
+            </a:r>
+            <a:r>
+              <a:rPr lang="en-US" altLang="en-US" dirty="0">
+                <a:solidFill>
+                  <a:schemeClr val="tx1"/>
+                </a:solidFill>
+              </a:rPr>
+              <a:t> hierarchy.</a:t>
             </a:r>
           </a:p>
           <a:p>
             <a:pPr lvl="1" eaLnBrk="1" hangingPunct="1"/>
-            <a:endParaRPr lang="en-US" altLang="en-US" dirty="0"/>
+            <a:endParaRPr lang="en-US" altLang="en-US" dirty="0">
+              <a:solidFill>
+                <a:schemeClr val="tx1"/>
+              </a:solidFill>
+            </a:endParaRPr>
           </a:p>
           <a:p>
             <a:pPr lvl="1" eaLnBrk="1" hangingPunct="1"/>
             <a:r>
-              <a:rPr lang="en-US" altLang="en-US" dirty="0" err="1"/>
-              <a:t>Eg</a:t>
+              <a:rPr lang="en-US" altLang="en-US" dirty="0">
+                <a:solidFill>
+                  <a:schemeClr val="tx1"/>
+                </a:solidFill>
+              </a:rPr>
+              <a:t>The derived class can</a:t>
             </a:r>
             <a:r>
               <a:rPr lang="en-US" altLang="en-US" dirty="0"/>
-              <a:t>: the </a:t>
+              <a:t> </a:t>
+            </a:r>
+            <a:r>
+              <a:rPr lang="en-US" altLang="en-US" b="1" dirty="0">
+                <a:solidFill>
+                  <a:srgbClr val="7030A0"/>
+                </a:solidFill>
+              </a:rPr>
+              <a:t>re-implement</a:t>
+            </a:r>
+            <a:r>
+              <a:rPr lang="en-US" altLang="en-US" dirty="0"/>
+              <a:t> </a:t>
             </a:r>
             <a:r>
               <a:rPr lang="en-US" altLang="en-US" dirty="0">
                 <a:solidFill>
-                  <a:srgbClr val="800000"/>
-                </a:solidFill>
-              </a:rPr>
-              <a:t>print ()</a:t>
+                  <a:schemeClr val="tx1"/>
+                </a:solidFill>
+              </a:rPr>
+              <a:t>the inherited method </a:t>
+            </a:r>
+            <a:br>
+              <a:rPr lang="en-US" altLang="en-US" dirty="0">
+                <a:solidFill>
+                  <a:schemeClr val="tx1"/>
+                </a:solidFill>
+              </a:rPr>
+            </a:br>
+            <a:r>
+              <a:rPr lang="en-US" altLang="en-US" dirty="0">
+                <a:solidFill>
+                  <a:schemeClr val="tx1"/>
+                </a:solidFill>
+              </a:rPr>
+              <a:t>(</a:t>
+            </a:r>
+            <a:r>
+              <a:rPr lang="en-US" altLang="en-US" b="1" dirty="0">
+                <a:solidFill>
+                  <a:srgbClr val="7030A0"/>
+                </a:solidFill>
+              </a:rPr>
+              <a:t>replacement</a:t>
             </a:r>
             <a:r>
               <a:rPr lang="en-US" altLang="en-US" dirty="0"/>
-              <a:t> in classes Circle and Rectangle in </a:t>
-            </a:r>
-            <a:r>
-              <a:rPr lang="en-US" altLang="en-US" b="1" dirty="0"/>
-              <a:t>Shapes</a:t>
-            </a:r>
-            <a:r>
-              <a:rPr lang="en-US" altLang="en-US" dirty="0"/>
-              <a:t> hierarchy.</a:t>
-            </a:r>
-          </a:p>
-          <a:p>
-            <a:pPr lvl="1" eaLnBrk="1" hangingPunct="1"/>
-            <a:endParaRPr lang="en-US" altLang="en-US" dirty="0"/>
-          </a:p>
-          <a:p>
-            <a:pPr lvl="1" eaLnBrk="1" hangingPunct="1"/>
-            <a:r>
-              <a:rPr lang="en-US" altLang="en-US" dirty="0"/>
-              <a:t>The derived class can </a:t>
-            </a:r>
-            <a:r>
-              <a:rPr lang="en-US" altLang="en-US" b="1" dirty="0">
-                <a:solidFill>
-                  <a:srgbClr val="7030A0"/>
-                </a:solidFill>
-              </a:rPr>
-              <a:t>re-implement</a:t>
-            </a:r>
-            <a:r>
-              <a:rPr lang="en-US" altLang="en-US" dirty="0"/>
-              <a:t> the inherited method </a:t>
-            </a:r>
-            <a:br>
-              <a:rPr lang="en-US" altLang="en-US" dirty="0"/>
-            </a:br>
-            <a:r>
-              <a:rPr lang="en-US" altLang="en-US" dirty="0"/>
-              <a:t>(</a:t>
-            </a:r>
-            <a:r>
-              <a:rPr lang="en-US" altLang="en-US" b="1" dirty="0">
-                <a:solidFill>
-                  <a:srgbClr val="7030A0"/>
-                </a:solidFill>
-              </a:rPr>
-              <a:t>replacement</a:t>
-            </a:r>
-            <a:r>
-              <a:rPr lang="en-US" altLang="en-US" dirty="0"/>
-              <a:t> for better performance). </a:t>
+              <a:t> </a:t>
+            </a:r>
+            <a:r>
+              <a:rPr lang="en-US" altLang="en-US" dirty="0">
+                <a:solidFill>
+                  <a:schemeClr val="tx1"/>
+                </a:solidFill>
+              </a:rPr>
+              <a:t>for better performance). </a:t>
             </a:r>
           </a:p>
         </p:txBody>
@@ -11297,6 +11460,33 @@
                 </a:solidFill>
               </a:rPr>
               <a:t>, not at compile time! </a:t>
+            </a:r>
+          </a:p>
+          <a:p>
+            <a:pPr eaLnBrk="1" hangingPunct="1">
+              <a:lnSpc>
+                <a:spcPct val="90000"/>
+              </a:lnSpc>
+            </a:pPr>
+            <a:endParaRPr lang="en-US" altLang="en-US" sz="2800" dirty="0">
+              <a:solidFill>
+                <a:schemeClr val="tx1"/>
+              </a:solidFill>
+            </a:endParaRPr>
+          </a:p>
+          <a:p>
+            <a:pPr eaLnBrk="1" hangingPunct="1">
+              <a:lnSpc>
+                <a:spcPct val="90000"/>
+              </a:lnSpc>
+            </a:pPr>
+            <a:r>
+              <a:rPr lang="en-US" altLang="en-US" sz="2800" dirty="0">
+                <a:solidFill>
+                  <a:schemeClr val="tx1"/>
+                </a:solidFill>
+              </a:rPr>
+              <a:t>Use @Override </a:t>
             </a:r>
           </a:p>
           <a:p>
@@ -18591,7 +18781,10 @@
           <a:prstGeom prst="straightConnector1">
             <a:avLst/>
           </a:prstGeom>
-          <a:ln>
+          <a:ln w="28575">
+            <a:solidFill>
+              <a:srgbClr val="FF0000"/>
+            </a:solidFill>
             <a:tailEnd type="triangle"/>
           </a:ln>
         </p:spPr>
@@ -19348,7 +19541,10 @@
           <a:prstGeom prst="straightConnector1">
             <a:avLst/>
           </a:prstGeom>
-          <a:ln>
+          <a:ln w="19050">
+            <a:solidFill>
+              <a:srgbClr val="FF0000"/>
+            </a:solidFill>
             <a:tailEnd type="triangle"/>
           </a:ln>
         </p:spPr>
@@ -19381,7 +19577,10 @@
           <a:prstGeom prst="straightConnector1">
             <a:avLst/>
           </a:prstGeom>
-          <a:ln>
+          <a:ln w="19050">
+            <a:solidFill>
+              <a:srgbClr val="FF0000"/>
+            </a:solidFill>
             <a:tailEnd type="triangle"/>
           </a:ln>
         </p:spPr>

</xml_diff>